<commit_message>
docs: add prominent live presentation section for index.html in README
</commit_message>
<xml_diff>
--- a/presentation/StagingGuard_AgntID_Pitch.pptx
+++ b/presentation/StagingGuard_AgntID_Pitch.pptx
@@ -3172,7 +3172,7 @@
               </a:defRPr>
             </a:pPr>
             <a:r>
-              <a:t>AGNTID HACKATHON 2026  •  AI DEVOPS TRACK</a:t>
+              <a:t>AGNTID HACKATHON 2026  •  DEVOPS BOUNDARY PROOF</a:t>
             </a:r>
           </a:p>
           <a:p>
@@ -3386,7 +3386,7 @@
               </a:defRPr>
             </a:pPr>
             <a:r>
-              <a:t>LLM-based DevOps agents need access to tools, but lack runtime security boundaries.</a:t>
+              <a:t>DevOps agents need useful tools and an enforced staging boundary.</a:t>
             </a:r>
           </a:p>
         </p:txBody>
@@ -3567,7 +3567,7 @@
               </a:defRPr>
             </a:pPr>
             <a:r>
-              <a:t>2. Hallucinated Scope Creep</a:t>
+              <a:t>2. Excessive Authority</a:t>
             </a:r>
           </a:p>
           <a:p>
@@ -3580,7 +3580,7 @@
               </a:defRPr>
             </a:pPr>
             <a:r>
-              <a:t>Prompted to fix staging, the agent explores files, inspects .env, unearths production AWS master secrets, and deletes production database volumes.</a:t>
+              <a:t>Our scripted baseline demonstrates secret exposure and production deletion in a disposable mock.</a:t>
             </a:r>
           </a:p>
         </p:txBody>
@@ -3664,7 +3664,7 @@
               </a:defRPr>
             </a:pPr>
             <a:r>
-              <a:t>3. Prompt Defense Fails</a:t>
+              <a:t>3. Runtime Checks Needed</a:t>
             </a:r>
           </a:p>
           <a:p>
@@ -3677,7 +3677,7 @@
               </a:defRPr>
             </a:pPr>
             <a:r>
-              <a:t>System prompts like 'Never touch production' fail against prompt injection, context window overflow, and complex multi-step reasoning drift.</a:t>
+              <a:t>A staging-only instruction does not itself restrict the tool parameters an agent can send.</a:t>
             </a:r>
           </a:p>
         </p:txBody>
@@ -3810,7 +3810,7 @@
               </a:defRPr>
             </a:pPr>
             <a:r>
-              <a:t>What The Unrestricted Agent Did</a:t>
+              <a:t>What Unrestricted Calls Can Do</a:t>
             </a:r>
           </a:p>
         </p:txBody>
@@ -3846,7 +3846,7 @@
               </a:defRPr>
             </a:pPr>
             <a:r>
-              <a:t>Demonstration of raw tool invocation without runtime guardrails.</a:t>
+              <a:t>Actual MCP calls; deterministic baseline; entirely synthetic infrastructure.</a:t>
             </a:r>
           </a:p>
         </p:txBody>
@@ -3927,7 +3927,7 @@
               </a:defRPr>
             </a:pPr>
             <a:r>
-              <a:t>AGENT EXECUTION LOG (BEFORE AGNTID):</a:t>
+              <a:t>DETERMINISTIC BASELINE (SYNTHETIC):</a:t>
             </a:r>
           </a:p>
           <a:p>
@@ -3975,7 +3975,7 @@
               </a:defRPr>
             </a:pPr>
             <a:r>
-              <a:t>→ Tool: infra.read_file(path='.env') =&gt; EXPOSES MASTER AWS &amp; DB TOKENS</a:t>
+              <a:t>→ Tool: infra.read_file(path='.env') =&gt; RETURNS A SYNTHETIC SECRET TRAP</a:t>
             </a:r>
           </a:p>
           <a:p>
@@ -4023,7 +4023,7 @@
               </a:defRPr>
             </a:pPr>
             <a:r>
-              <a:t>💥 CATASTROPHE: 142,500 Customer records permanently deleted!</a:t>
+              <a:t>💥 Fixture state: 142,500 simulated records erased</a:t>
             </a:r>
           </a:p>
           <a:p>
@@ -4039,7 +4039,7 @@
               </a:defRPr>
             </a:pPr>
             <a:r>
-              <a:t>💥 OUTAGE: Staging remains broken; Production is destroyed.</a:t>
+              <a:t>💥 Simulated production erased; staging still failing</a:t>
             </a:r>
           </a:p>
         </p:txBody>
@@ -4123,7 +4123,7 @@
               </a:defRPr>
             </a:pPr>
             <a:r>
-              <a:t>Real-World Impact</a:t>
+              <a:t>Measured Fixture Outcome</a:t>
             </a:r>
           </a:p>
           <a:p>
@@ -4136,22 +4136,22 @@
               </a:defRPr>
             </a:pPr>
             <a:r>
-              <a:t>• Secrets Stolen: AWS Master Key &amp; Prod DB Credentials leaked via .env</a:t>
+              <a:t>• Synthetic secret trap reachable; payload omitted</a:t>
             </a:r>
             <a:br/>
             <a:br/>
             <a:r>
-              <a:t>• Data Loss: 142,500 active customer rows wiped on production</a:t>
+              <a:t>• Mock data loss: 142,500 simulated records</a:t>
             </a:r>
             <a:br/>
             <a:br/>
             <a:r>
-              <a:t>• Zero Auditability: No centralized record of agent intent vs tool execution</a:t>
+              <a:t>• Baseline: direct mock access without AgntID</a:t>
             </a:r>
             <a:br/>
             <a:br/>
             <a:r>
-              <a:t>• Task Failure: The actual staging bug was never resolved</a:t>
+              <a:t>• Staging fixture remains failing</a:t>
             </a:r>
           </a:p>
         </p:txBody>
@@ -4404,7 +4404,7 @@
               </a:defRPr>
             </a:pPr>
             <a:r>
-              <a:t>PERMITTED ACTIONS (STAGING ONLY)</a:t>
+              <a:t>PERMITTED TASK ACTIONS</a:t>
             </a:r>
           </a:p>
           <a:p>
@@ -4554,11 +4554,11 @@
             <a:br/>
             <a:br/>
             <a:r>
-              <a:t>⛔ Any action targeting env='prod'</a:t>
+              <a:t>⛔ update_config(env='prod')</a:t>
             </a:r>
             <a:br/>
             <a:r>
-              <a:t>BLOCKED: Production blast radius completely isolated.</a:t>
+              <a:t>DENIED: only exact env=staging writes allowed.</a:t>
             </a:r>
           </a:p>
         </p:txBody>
@@ -4811,7 +4811,7 @@
               </a:defRPr>
             </a:pPr>
             <a:r>
-              <a:t>1. Autonomous Agent</a:t>
+              <a:t>1. Agent and Proof Client</a:t>
             </a:r>
           </a:p>
           <a:p>
@@ -4824,7 +4824,7 @@
               </a:defRPr>
             </a:pPr>
             <a:r>
-              <a:t>• LangChain / MCP Client</a:t>
+              <a:t>• Codex MCP agent + deterministic SDK proof</a:t>
             </a:r>
             <a:br/>
             <a:r>
@@ -4836,7 +4836,7 @@
             </a:r>
             <a:br/>
             <a:r>
-              <a:t>• Session &amp; Task Context linked via agntid-sdk</a:t>
+              <a:t>• Discovered task metadata linked via official SDK</a:t>
             </a:r>
           </a:p>
         </p:txBody>
@@ -5046,11 +5046,11 @@
             </a:r>
             <a:br/>
             <a:r>
-              <a:t>• Only verified, policy-approved requests reach upstream tools</a:t>
+              <a:t>• Protected business calls route through the proxy</a:t>
             </a:r>
             <a:br/>
             <a:r>
-              <a:t>• Full compliance guaranteed</a:t>
+              <a:t>• Raw backend isolation is not demonstrated</a:t>
             </a:r>
           </a:p>
         </p:txBody>
@@ -5219,7 +5219,7 @@
               </a:defRPr>
             </a:pPr>
             <a:r>
-              <a:t>AgntID enforces boundaries at runtime: zero hallucinations succeed.</a:t>
+              <a:t>Three controls verified with real proxy calls and backend assertions.</a:t>
             </a:r>
           </a:p>
         </p:txBody>
@@ -5300,7 +5300,7 @@
               </a:defRPr>
             </a:pPr>
             <a:r>
-              <a:t>AGNTID RUNTIME EXECUTION LOG (LIVE):</a:t>
+              <a:t>VERIFIED PROXY EXECUTION (SYNTHETIC):</a:t>
             </a:r>
           </a:p>
           <a:p>
@@ -5412,7 +5412,7 @@
               </a:defRPr>
             </a:pPr>
             <a:r>
-              <a:t>🎉 Staging service recovered to HEALTHY; Prod 100% Intact!</a:t>
+              <a:t>🎉 Staging healthy; production state/hash unchanged</a:t>
             </a:r>
           </a:p>
         </p:txBody>
@@ -5519,7 +5519,7 @@
             <a:br/>
             <a:br/>
             <a:r>
-              <a:t>🛡️ Production Safe: 142,500 customer records untouched</a:t>
+              <a:t>🛡️ Production fixture: 142,500 simulated records retained</a:t>
             </a:r>
             <a:br/>
             <a:br/>
@@ -5693,7 +5693,7 @@
               </a:defRPr>
             </a:pPr>
             <a:r>
-              <a:t>Clear empirical comparison across enterprise security metrics.</a:t>
+              <a:t>Measured before/after comparison of the same disposable fixture.</a:t>
             </a:r>
           </a:p>
         </p:txBody>
@@ -5858,7 +5858,7 @@
                         </a:defRPr>
                       </a:pPr>
                       <a:r>
-                        <a:t>✅ 100% OPERATIONAL (Protected)</a:t>
+                        <a:t>✅ State and Config Unchanged</a:t>
                       </a:r>
                     </a:p>
                   </a:txBody>
@@ -5884,7 +5884,7 @@
                         </a:defRPr>
                       </a:pPr>
                       <a:r>
-                        <a:t>Customer Records Lost</a:t>
+                        <a:t>Simulated Records Lost</a:t>
                       </a:r>
                     </a:p>
                   </a:txBody>
@@ -5908,7 +5908,7 @@
                         </a:defRPr>
                       </a:pPr>
                       <a:r>
-                        <a:t>142,500 Records Erased</a:t>
+                        <a:t>142,500 Simulated Records Erased</a:t>
                       </a:r>
                     </a:p>
                   </a:txBody>
@@ -5982,7 +5982,7 @@
                         </a:defRPr>
                       </a:pPr>
                       <a:r>
-                        <a:t>🚨 Leaked (Master AWS/DB keys)</a:t>
+                        <a:t>🚨 Synthetic Trap Returned</a:t>
                       </a:r>
                     </a:p>
                   </a:txBody>
@@ -6056,7 +6056,7 @@
                         </a:defRPr>
                       </a:pPr>
                       <a:r>
-                        <a:t>Unrestricted (All 7 tools exposed)</a:t>
+                        <a:t>7 business tools + 2 operator helpers</a:t>
                       </a:r>
                     </a:p>
                   </a:txBody>
@@ -6333,7 +6333,7 @@
               </a:defRPr>
             </a:pPr>
             <a:r>
-              <a:t>All criteria satisfied with reproducible codebase and live runtime.</a:t>
+              <a:t>Core proof verified; final submission and narrated video pending.</a:t>
             </a:r>
           </a:p>
         </p:txBody>
@@ -6430,7 +6430,7 @@
               </a:defRPr>
             </a:pPr>
             <a:r>
-              <a:t>• Track: AI DevOps Incident Remediation</a:t>
+              <a:t>• Use case: staging incident remediation</a:t>
             </a:r>
             <a:br/>
             <a:r>
@@ -6534,7 +6534,7 @@
               </a:defRPr>
             </a:pPr>
             <a:r>
-              <a:t>Judge &amp; Organizer Collaboration</a:t>
+              <a:t>Remaining Submission Steps</a:t>
             </a:r>
           </a:p>
           <a:p>
@@ -6547,30 +6547,30 @@
               </a:defRPr>
             </a:pPr>
             <a:r>
-              <a:t>Collaborator Access Granted in AgntID Portal:</a:t>
+              <a:t>Private repository; public access not ready.</a:t>
             </a:r>
             <a:br/>
             <a:br/>
             <a:r>
-              <a:t>✔ Organizer UUID 1:</a:t>
+              <a:t>Narrated backup video still needed.</a:t>
             </a:r>
             <a:br/>
             <a:r>
-              <a:t>95c8281c-cb8b-4b21-8395-5cb255552b21</a:t>
+              <a:t>Verify actual organizer collaborator requirements.</a:t>
             </a:r>
             <a:br/>
             <a:br/>
             <a:r>
-              <a:t>✔ Organizer UUID 2:</a:t>
+              <a:t>Devfolio submission not verified.</a:t>
             </a:r>
             <a:br/>
             <a:r>
-              <a:t>61671e35-5b43-455b-b9f0-2567406ae25d</a:t>
+              <a:t>No human approval enforcement claimed.</a:t>
             </a:r>
             <a:br/>
             <a:br/>
             <a:r>
-              <a:t>GitHub: https://github.com/akshatnaruka/AgntID</a:t>
+              <a:t>Repo: github.com/AkshatNaruka/StagingGuard (private)</a:t>
             </a:r>
           </a:p>
         </p:txBody>

</xml_diff>